<commit_message>
slide 047 straight-delimiter redo (founder PIL-only directive): re-applied after concurrent-lane restore reverted the fixed build; all 5 paren PNGs + row-vector font parens -> straight 1px bars (tl2 12 y77 h31, z 6 y80 h32, aug 12 y180 h46 909090; W x330.5/352 y57 h50 6E6E6E; triplet x330/x378 + stack x380.9/403.95 A6A6A6), digits re-laid (rowvec cx 336/353.5/369.5, stack cx 397->395); img()/ASSET removed; PIL 62/62 diff 18892px 0 strays, chrome PASS
</commit_message>
<xml_diff>
--- a/videos/machine-learning/03_ridger_regression_gradient_descent/recreated_pptx/slide_047_recreated.pptx
+++ b/videos/machine-learning/03_ridger_regression_gradient_descent/recreated_pptx/slide_047_recreated.pptx
@@ -1053,33 +1053,49 @@
           </a:ln>
         </p:spPr>
       </p:sp>
-      <p:pic>
-        <p:nvPicPr>
-          <p:cNvPr id="9" name="Image 0" descr="videos/machine-learning/03_ridger_regression_gradient_descent/recreated_pptx/build/assets/paren_p047_tl2.png">    </p:cNvPr>
-          <p:cNvPicPr>
-            <a:picLocks noChangeAspect="1"/>
-          </p:cNvPicPr>
-          <p:nvPr/>
-        </p:nvPicPr>
-        <p:blipFill>
-          <a:blip r:embed="rId1"/>
-          <a:stretch>
-            <a:fillRect/>
-          </a:stretch>
-        </p:blipFill>
-        <p:spPr>
-          <a:xfrm>
-            <a:off x="1125855" y="971550"/>
-            <a:ext cx="193548" cy="399288"/>
-          </a:xfrm>
-          <a:prstGeom prst="rect">
-            <a:avLst/>
-          </a:prstGeom>
-        </p:spPr>
-      </p:pic>
-      <p:sp>
-        <p:nvSpPr>
-          <p:cNvPr id="10" name="Text 7"/>
+      <p:sp>
+        <p:nvSpPr>
+          <p:cNvPr id="9" name="Shape 7"/>
+          <p:cNvSpPr/>
+          <p:nvPr/>
+        </p:nvSpPr>
+        <p:spPr>
+          <a:xfrm>
+            <a:off x="1140587" y="977900"/>
+            <a:ext cx="12700" cy="393700"/>
+          </a:xfrm>
+          <a:prstGeom prst="rect">
+            <a:avLst/>
+          </a:prstGeom>
+          <a:solidFill>
+            <a:srgbClr val="909090"/>
+          </a:solidFill>
+          <a:ln/>
+        </p:spPr>
+      </p:sp>
+      <p:sp>
+        <p:nvSpPr>
+          <p:cNvPr id="10" name="Shape 8"/>
+          <p:cNvSpPr/>
+          <p:nvPr/>
+        </p:nvSpPr>
+        <p:spPr>
+          <a:xfrm>
+            <a:off x="1276350" y="977900"/>
+            <a:ext cx="12700" cy="393700"/>
+          </a:xfrm>
+          <a:prstGeom prst="rect">
+            <a:avLst/>
+          </a:prstGeom>
+          <a:solidFill>
+            <a:srgbClr val="909090"/>
+          </a:solidFill>
+          <a:ln/>
+        </p:spPr>
+      </p:sp>
+      <p:sp>
+        <p:nvSpPr>
+          <p:cNvPr id="11" name="Text 9"/>
           <p:cNvSpPr/>
           <p:nvPr/>
         </p:nvSpPr>
@@ -1118,7 +1134,7 @@
       </p:sp>
       <p:sp>
         <p:nvSpPr>
-          <p:cNvPr id="11" name="Text 8"/>
+          <p:cNvPr id="12" name="Text 10"/>
           <p:cNvSpPr/>
           <p:nvPr/>
         </p:nvSpPr>
@@ -1157,7 +1173,7 @@
       </p:sp>
       <p:sp>
         <p:nvSpPr>
-          <p:cNvPr id="12" name="Text 9"/>
+          <p:cNvPr id="13" name="Text 11"/>
           <p:cNvSpPr/>
           <p:nvPr/>
         </p:nvSpPr>
@@ -1196,7 +1212,7 @@
       </p:sp>
       <p:sp>
         <p:nvSpPr>
-          <p:cNvPr id="13" name="Text 10"/>
+          <p:cNvPr id="14" name="Text 12"/>
           <p:cNvSpPr/>
           <p:nvPr/>
         </p:nvSpPr>
@@ -1233,33 +1249,49 @@
           </a:p>
         </p:txBody>
       </p:sp>
-      <p:pic>
-        <p:nvPicPr>
-          <p:cNvPr id="14" name="Image 1" descr="videos/machine-learning/03_ridger_regression_gradient_descent/recreated_pptx/build/assets/paren_p047_tl2.png">    </p:cNvPr>
-          <p:cNvPicPr>
-            <a:picLocks noChangeAspect="1"/>
-          </p:cNvPicPr>
-          <p:nvPr/>
-        </p:nvPicPr>
-        <p:blipFill>
-          <a:blip r:embed="rId2"/>
-          <a:stretch>
-            <a:fillRect/>
-          </a:stretch>
-        </p:blipFill>
-        <p:spPr>
-          <a:xfrm>
-            <a:off x="1405255" y="971550"/>
-            <a:ext cx="193548" cy="399288"/>
-          </a:xfrm>
-          <a:prstGeom prst="rect">
-            <a:avLst/>
-          </a:prstGeom>
-        </p:spPr>
-      </p:pic>
-      <p:sp>
-        <p:nvSpPr>
-          <p:cNvPr id="15" name="Text 11"/>
+      <p:sp>
+        <p:nvSpPr>
+          <p:cNvPr id="15" name="Shape 13"/>
+          <p:cNvSpPr/>
+          <p:nvPr/>
+        </p:nvSpPr>
+        <p:spPr>
+          <a:xfrm>
+            <a:off x="1415415" y="977900"/>
+            <a:ext cx="12700" cy="393700"/>
+          </a:xfrm>
+          <a:prstGeom prst="rect">
+            <a:avLst/>
+          </a:prstGeom>
+          <a:solidFill>
+            <a:srgbClr val="909090"/>
+          </a:solidFill>
+          <a:ln/>
+        </p:spPr>
+      </p:sp>
+      <p:sp>
+        <p:nvSpPr>
+          <p:cNvPr id="16" name="Shape 14"/>
+          <p:cNvSpPr/>
+          <p:nvPr/>
+        </p:nvSpPr>
+        <p:spPr>
+          <a:xfrm>
+            <a:off x="1560068" y="977900"/>
+            <a:ext cx="12700" cy="393700"/>
+          </a:xfrm>
+          <a:prstGeom prst="rect">
+            <a:avLst/>
+          </a:prstGeom>
+          <a:solidFill>
+            <a:srgbClr val="909090"/>
+          </a:solidFill>
+          <a:ln/>
+        </p:spPr>
+      </p:sp>
+      <p:sp>
+        <p:nvSpPr>
+          <p:cNvPr id="17" name="Text 15"/>
           <p:cNvSpPr/>
           <p:nvPr/>
         </p:nvSpPr>
@@ -1298,7 +1330,7 @@
       </p:sp>
       <p:sp>
         <p:nvSpPr>
-          <p:cNvPr id="16" name="Text 12"/>
+          <p:cNvPr id="18" name="Text 16"/>
           <p:cNvSpPr/>
           <p:nvPr/>
         </p:nvSpPr>
@@ -1337,7 +1369,7 @@
       </p:sp>
       <p:sp>
         <p:nvSpPr>
-          <p:cNvPr id="17" name="Text 13"/>
+          <p:cNvPr id="19" name="Text 17"/>
           <p:cNvSpPr/>
           <p:nvPr/>
         </p:nvSpPr>
@@ -1376,7 +1408,7 @@
       </p:sp>
       <p:sp>
         <p:nvSpPr>
-          <p:cNvPr id="18" name="Text 14"/>
+          <p:cNvPr id="20" name="Text 18"/>
           <p:cNvSpPr/>
           <p:nvPr/>
         </p:nvSpPr>
@@ -1413,33 +1445,49 @@
           </a:p>
         </p:txBody>
       </p:sp>
-      <p:pic>
-        <p:nvPicPr>
-          <p:cNvPr id="19" name="Image 2" descr="videos/machine-learning/03_ridger_regression_gradient_descent/recreated_pptx/build/assets/paren_p047_tl2.png">    </p:cNvPr>
-          <p:cNvPicPr>
-            <a:picLocks noChangeAspect="1"/>
-          </p:cNvPicPr>
-          <p:nvPr/>
-        </p:nvPicPr>
-        <p:blipFill>
-          <a:blip r:embed="rId3"/>
-          <a:stretch>
-            <a:fillRect/>
-          </a:stretch>
-        </p:blipFill>
-        <p:spPr>
-          <a:xfrm>
-            <a:off x="1684274" y="971550"/>
-            <a:ext cx="193548" cy="399288"/>
-          </a:xfrm>
-          <a:prstGeom prst="rect">
-            <a:avLst/>
-          </a:prstGeom>
-        </p:spPr>
-      </p:pic>
-      <p:sp>
-        <p:nvSpPr>
-          <p:cNvPr id="20" name="Text 15"/>
+      <p:sp>
+        <p:nvSpPr>
+          <p:cNvPr id="21" name="Shape 19"/>
+          <p:cNvSpPr/>
+          <p:nvPr/>
+        </p:nvSpPr>
+        <p:spPr>
+          <a:xfrm>
+            <a:off x="1695958" y="977900"/>
+            <a:ext cx="12700" cy="393700"/>
+          </a:xfrm>
+          <a:prstGeom prst="rect">
+            <a:avLst/>
+          </a:prstGeom>
+          <a:solidFill>
+            <a:srgbClr val="909090"/>
+          </a:solidFill>
+          <a:ln/>
+        </p:spPr>
+      </p:sp>
+      <p:sp>
+        <p:nvSpPr>
+          <p:cNvPr id="22" name="Shape 20"/>
+          <p:cNvSpPr/>
+          <p:nvPr/>
+        </p:nvSpPr>
+        <p:spPr>
+          <a:xfrm>
+            <a:off x="1842770" y="977900"/>
+            <a:ext cx="12700" cy="393700"/>
+          </a:xfrm>
+          <a:prstGeom prst="rect">
+            <a:avLst/>
+          </a:prstGeom>
+          <a:solidFill>
+            <a:srgbClr val="909090"/>
+          </a:solidFill>
+          <a:ln/>
+        </p:spPr>
+      </p:sp>
+      <p:sp>
+        <p:nvSpPr>
+          <p:cNvPr id="23" name="Text 21"/>
           <p:cNvSpPr/>
           <p:nvPr/>
         </p:nvSpPr>
@@ -1478,7 +1526,7 @@
       </p:sp>
       <p:sp>
         <p:nvSpPr>
-          <p:cNvPr id="21" name="Text 16"/>
+          <p:cNvPr id="24" name="Text 22"/>
           <p:cNvSpPr/>
           <p:nvPr/>
         </p:nvSpPr>
@@ -1517,7 +1565,7 @@
       </p:sp>
       <p:sp>
         <p:nvSpPr>
-          <p:cNvPr id="22" name="Text 17"/>
+          <p:cNvPr id="25" name="Text 23"/>
           <p:cNvSpPr/>
           <p:nvPr/>
         </p:nvSpPr>
@@ -1556,7 +1604,7 @@
       </p:sp>
       <p:sp>
         <p:nvSpPr>
-          <p:cNvPr id="23" name="Text 18"/>
+          <p:cNvPr id="26" name="Text 24"/>
           <p:cNvSpPr/>
           <p:nvPr/>
         </p:nvSpPr>
@@ -1593,33 +1641,49 @@
           </a:p>
         </p:txBody>
       </p:sp>
-      <p:pic>
-        <p:nvPicPr>
-          <p:cNvPr id="24" name="Image 3" descr="videos/machine-learning/03_ridger_regression_gradient_descent/recreated_pptx/build/assets/paren_p047_tl2.png">    </p:cNvPr>
-          <p:cNvPicPr>
-            <a:picLocks noChangeAspect="1"/>
-          </p:cNvPicPr>
-          <p:nvPr/>
-        </p:nvPicPr>
-        <p:blipFill>
-          <a:blip r:embed="rId4"/>
-          <a:stretch>
-            <a:fillRect/>
-          </a:stretch>
-        </p:blipFill>
-        <p:spPr>
-          <a:xfrm>
-            <a:off x="1969643" y="971550"/>
-            <a:ext cx="193548" cy="399288"/>
-          </a:xfrm>
-          <a:prstGeom prst="rect">
-            <a:avLst/>
-          </a:prstGeom>
-        </p:spPr>
-      </p:pic>
-      <p:sp>
-        <p:nvSpPr>
-          <p:cNvPr id="25" name="Text 19"/>
+      <p:sp>
+        <p:nvSpPr>
+          <p:cNvPr id="27" name="Shape 25"/>
+          <p:cNvSpPr/>
+          <p:nvPr/>
+        </p:nvSpPr>
+        <p:spPr>
+          <a:xfrm>
+            <a:off x="1985010" y="977900"/>
+            <a:ext cx="12700" cy="393700"/>
+          </a:xfrm>
+          <a:prstGeom prst="rect">
+            <a:avLst/>
+          </a:prstGeom>
+          <a:solidFill>
+            <a:srgbClr val="909090"/>
+          </a:solidFill>
+          <a:ln/>
+        </p:spPr>
+      </p:sp>
+      <p:sp>
+        <p:nvSpPr>
+          <p:cNvPr id="28" name="Shape 26"/>
+          <p:cNvSpPr/>
+          <p:nvPr/>
+        </p:nvSpPr>
+        <p:spPr>
+          <a:xfrm>
+            <a:off x="2134362" y="977900"/>
+            <a:ext cx="12700" cy="393700"/>
+          </a:xfrm>
+          <a:prstGeom prst="rect">
+            <a:avLst/>
+          </a:prstGeom>
+          <a:solidFill>
+            <a:srgbClr val="909090"/>
+          </a:solidFill>
+          <a:ln/>
+        </p:spPr>
+      </p:sp>
+      <p:sp>
+        <p:nvSpPr>
+          <p:cNvPr id="29" name="Text 27"/>
           <p:cNvSpPr/>
           <p:nvPr/>
         </p:nvSpPr>
@@ -1658,7 +1722,7 @@
       </p:sp>
       <p:sp>
         <p:nvSpPr>
-          <p:cNvPr id="26" name="Text 20"/>
+          <p:cNvPr id="30" name="Text 28"/>
           <p:cNvSpPr/>
           <p:nvPr/>
         </p:nvSpPr>
@@ -1697,7 +1761,7 @@
       </p:sp>
       <p:sp>
         <p:nvSpPr>
-          <p:cNvPr id="27" name="Text 21"/>
+          <p:cNvPr id="31" name="Text 29"/>
           <p:cNvSpPr/>
           <p:nvPr/>
         </p:nvSpPr>
@@ -1736,7 +1800,7 @@
       </p:sp>
       <p:sp>
         <p:nvSpPr>
-          <p:cNvPr id="28" name="Text 22"/>
+          <p:cNvPr id="32" name="Text 30"/>
           <p:cNvSpPr/>
           <p:nvPr/>
         </p:nvSpPr>
@@ -1773,33 +1837,49 @@
           </a:p>
         </p:txBody>
       </p:sp>
-      <p:pic>
-        <p:nvPicPr>
-          <p:cNvPr id="29" name="Image 4" descr="videos/machine-learning/03_ridger_regression_gradient_descent/recreated_pptx/build/assets/paren_p047_tl2.png">    </p:cNvPr>
-          <p:cNvPicPr>
-            <a:picLocks noChangeAspect="1"/>
-          </p:cNvPicPr>
-          <p:nvPr/>
-        </p:nvPicPr>
-        <p:blipFill>
-          <a:blip r:embed="rId5"/>
-          <a:stretch>
-            <a:fillRect/>
-          </a:stretch>
-        </p:blipFill>
-        <p:spPr>
-          <a:xfrm>
-            <a:off x="2255393" y="971550"/>
-            <a:ext cx="193548" cy="399288"/>
-          </a:xfrm>
-          <a:prstGeom prst="rect">
-            <a:avLst/>
-          </a:prstGeom>
-        </p:spPr>
-      </p:pic>
-      <p:sp>
-        <p:nvSpPr>
-          <p:cNvPr id="30" name="Text 23"/>
+      <p:sp>
+        <p:nvSpPr>
+          <p:cNvPr id="33" name="Shape 31"/>
+          <p:cNvSpPr/>
+          <p:nvPr/>
+        </p:nvSpPr>
+        <p:spPr>
+          <a:xfrm>
+            <a:off x="2270125" y="977900"/>
+            <a:ext cx="12700" cy="393700"/>
+          </a:xfrm>
+          <a:prstGeom prst="rect">
+            <a:avLst/>
+          </a:prstGeom>
+          <a:solidFill>
+            <a:srgbClr val="909090"/>
+          </a:solidFill>
+          <a:ln/>
+        </p:spPr>
+      </p:sp>
+      <p:sp>
+        <p:nvSpPr>
+          <p:cNvPr id="34" name="Shape 32"/>
+          <p:cNvSpPr/>
+          <p:nvPr/>
+        </p:nvSpPr>
+        <p:spPr>
+          <a:xfrm>
+            <a:off x="2410206" y="977900"/>
+            <a:ext cx="12700" cy="393700"/>
+          </a:xfrm>
+          <a:prstGeom prst="rect">
+            <a:avLst/>
+          </a:prstGeom>
+          <a:solidFill>
+            <a:srgbClr val="909090"/>
+          </a:solidFill>
+          <a:ln/>
+        </p:spPr>
+      </p:sp>
+      <p:sp>
+        <p:nvSpPr>
+          <p:cNvPr id="35" name="Text 33"/>
           <p:cNvSpPr/>
           <p:nvPr/>
         </p:nvSpPr>
@@ -1838,7 +1918,7 @@
       </p:sp>
       <p:sp>
         <p:nvSpPr>
-          <p:cNvPr id="31" name="Text 24"/>
+          <p:cNvPr id="36" name="Text 34"/>
           <p:cNvSpPr/>
           <p:nvPr/>
         </p:nvSpPr>
@@ -1877,7 +1957,7 @@
       </p:sp>
       <p:sp>
         <p:nvSpPr>
-          <p:cNvPr id="32" name="Text 25"/>
+          <p:cNvPr id="37" name="Text 35"/>
           <p:cNvSpPr/>
           <p:nvPr/>
         </p:nvSpPr>
@@ -1916,7 +1996,7 @@
       </p:sp>
       <p:sp>
         <p:nvSpPr>
-          <p:cNvPr id="33" name="Text 26"/>
+          <p:cNvPr id="38" name="Text 36"/>
           <p:cNvSpPr/>
           <p:nvPr/>
         </p:nvSpPr>
@@ -1953,33 +2033,49 @@
           </a:p>
         </p:txBody>
       </p:sp>
-      <p:pic>
-        <p:nvPicPr>
-          <p:cNvPr id="34" name="Image 5" descr="videos/machine-learning/03_ridger_regression_gradient_descent/recreated_pptx/build/assets/paren_p047_tl2.png">    </p:cNvPr>
-          <p:cNvPicPr>
-            <a:picLocks noChangeAspect="1"/>
-          </p:cNvPicPr>
-          <p:nvPr/>
-        </p:nvPicPr>
-        <p:blipFill>
-          <a:blip r:embed="rId6"/>
-          <a:stretch>
-            <a:fillRect/>
-          </a:stretch>
-        </p:blipFill>
-        <p:spPr>
-          <a:xfrm>
-            <a:off x="2548255" y="971550"/>
-            <a:ext cx="193548" cy="399288"/>
-          </a:xfrm>
-          <a:prstGeom prst="rect">
-            <a:avLst/>
-          </a:prstGeom>
-        </p:spPr>
-      </p:pic>
-      <p:sp>
-        <p:nvSpPr>
-          <p:cNvPr id="35" name="Text 27"/>
+      <p:sp>
+        <p:nvSpPr>
+          <p:cNvPr id="39" name="Shape 37"/>
+          <p:cNvSpPr/>
+          <p:nvPr/>
+        </p:nvSpPr>
+        <p:spPr>
+          <a:xfrm>
+            <a:off x="2561463" y="977900"/>
+            <a:ext cx="12700" cy="393700"/>
+          </a:xfrm>
+          <a:prstGeom prst="rect">
+            <a:avLst/>
+          </a:prstGeom>
+          <a:solidFill>
+            <a:srgbClr val="909090"/>
+          </a:solidFill>
+          <a:ln/>
+        </p:spPr>
+      </p:sp>
+      <p:sp>
+        <p:nvSpPr>
+          <p:cNvPr id="40" name="Shape 38"/>
+          <p:cNvSpPr/>
+          <p:nvPr/>
+        </p:nvSpPr>
+        <p:spPr>
+          <a:xfrm>
+            <a:off x="2696972" y="977900"/>
+            <a:ext cx="12700" cy="393700"/>
+          </a:xfrm>
+          <a:prstGeom prst="rect">
+            <a:avLst/>
+          </a:prstGeom>
+          <a:solidFill>
+            <a:srgbClr val="909090"/>
+          </a:solidFill>
+          <a:ln/>
+        </p:spPr>
+      </p:sp>
+      <p:sp>
+        <p:nvSpPr>
+          <p:cNvPr id="41" name="Text 39"/>
           <p:cNvSpPr/>
           <p:nvPr/>
         </p:nvSpPr>
@@ -2018,7 +2114,7 @@
       </p:sp>
       <p:sp>
         <p:nvSpPr>
-          <p:cNvPr id="36" name="Text 28"/>
+          <p:cNvPr id="42" name="Text 40"/>
           <p:cNvSpPr/>
           <p:nvPr/>
         </p:nvSpPr>
@@ -2057,7 +2153,7 @@
       </p:sp>
       <p:sp>
         <p:nvSpPr>
-          <p:cNvPr id="37" name="Text 29"/>
+          <p:cNvPr id="43" name="Text 41"/>
           <p:cNvSpPr/>
           <p:nvPr/>
         </p:nvSpPr>
@@ -2096,7 +2192,7 @@
       </p:sp>
       <p:sp>
         <p:nvSpPr>
-          <p:cNvPr id="38" name="Text 30"/>
+          <p:cNvPr id="44" name="Text 42"/>
           <p:cNvSpPr/>
           <p:nvPr/>
         </p:nvSpPr>
@@ -2135,7 +2231,7 @@
       </p:sp>
       <p:sp>
         <p:nvSpPr>
-          <p:cNvPr id="39" name="Text 31"/>
+          <p:cNvPr id="45" name="Text 43"/>
           <p:cNvSpPr/>
           <p:nvPr/>
         </p:nvSpPr>
@@ -2200,33 +2296,49 @@
           </a:p>
         </p:txBody>
       </p:sp>
-      <p:pic>
-        <p:nvPicPr>
-          <p:cNvPr id="40" name="Image 6" descr="videos/machine-learning/03_ridger_regression_gradient_descent/recreated_pptx/build/assets/paren_p047_w.png">    </p:cNvPr>
-          <p:cNvPicPr>
-            <a:picLocks noChangeAspect="1"/>
-          </p:cNvPicPr>
-          <p:nvPr/>
-        </p:nvPicPr>
-        <p:blipFill>
-          <a:blip r:embed="rId7"/>
-          <a:stretch>
-            <a:fillRect/>
-          </a:stretch>
-        </p:blipFill>
-        <p:spPr>
-          <a:xfrm>
-            <a:off x="4140200" y="736600"/>
-            <a:ext cx="393700" cy="601980"/>
-          </a:xfrm>
-          <a:prstGeom prst="rect">
-            <a:avLst/>
-          </a:prstGeom>
-        </p:spPr>
-      </p:pic>
-      <p:sp>
-        <p:nvSpPr>
-          <p:cNvPr id="41" name="Text 32"/>
+      <p:sp>
+        <p:nvSpPr>
+          <p:cNvPr id="46" name="Shape 44"/>
+          <p:cNvSpPr/>
+          <p:nvPr/>
+        </p:nvSpPr>
+        <p:spPr>
+          <a:xfrm>
+            <a:off x="4197350" y="723900"/>
+            <a:ext cx="12700" cy="635000"/>
+          </a:xfrm>
+          <a:prstGeom prst="rect">
+            <a:avLst/>
+          </a:prstGeom>
+          <a:solidFill>
+            <a:srgbClr val="6E6E6E"/>
+          </a:solidFill>
+          <a:ln/>
+        </p:spPr>
+      </p:sp>
+      <p:sp>
+        <p:nvSpPr>
+          <p:cNvPr id="47" name="Shape 45"/>
+          <p:cNvSpPr/>
+          <p:nvPr/>
+        </p:nvSpPr>
+        <p:spPr>
+          <a:xfrm>
+            <a:off x="4470400" y="723900"/>
+            <a:ext cx="12700" cy="635000"/>
+          </a:xfrm>
+          <a:prstGeom prst="rect">
+            <a:avLst/>
+          </a:prstGeom>
+          <a:solidFill>
+            <a:srgbClr val="6E6E6E"/>
+          </a:solidFill>
+          <a:ln/>
+        </p:spPr>
+      </p:sp>
+      <p:sp>
+        <p:nvSpPr>
+          <p:cNvPr id="48" name="Text 46"/>
           <p:cNvSpPr/>
           <p:nvPr/>
         </p:nvSpPr>
@@ -2265,7 +2377,7 @@
       </p:sp>
       <p:sp>
         <p:nvSpPr>
-          <p:cNvPr id="42" name="Text 33"/>
+          <p:cNvPr id="49" name="Text 47"/>
           <p:cNvSpPr/>
           <p:nvPr/>
         </p:nvSpPr>
@@ -2304,7 +2416,7 @@
       </p:sp>
       <p:sp>
         <p:nvSpPr>
-          <p:cNvPr id="43" name="Text 34"/>
+          <p:cNvPr id="50" name="Text 48"/>
           <p:cNvSpPr/>
           <p:nvPr/>
         </p:nvSpPr>
@@ -2343,7 +2455,7 @@
       </p:sp>
       <p:sp>
         <p:nvSpPr>
-          <p:cNvPr id="44" name="Text 35"/>
+          <p:cNvPr id="51" name="Text 49"/>
           <p:cNvSpPr/>
           <p:nvPr/>
         </p:nvSpPr>
@@ -2382,7 +2494,7 @@
       </p:sp>
       <p:sp>
         <p:nvSpPr>
-          <p:cNvPr id="45" name="Text 36"/>
+          <p:cNvPr id="52" name="Text 50"/>
           <p:cNvSpPr/>
           <p:nvPr/>
         </p:nvSpPr>
@@ -2421,7 +2533,7 @@
       </p:sp>
       <p:sp>
         <p:nvSpPr>
-          <p:cNvPr id="46" name="Text 37"/>
+          <p:cNvPr id="53" name="Text 51"/>
           <p:cNvSpPr/>
           <p:nvPr/>
         </p:nvSpPr>
@@ -2528,33 +2640,49 @@
           </a:p>
         </p:txBody>
       </p:sp>
-      <p:pic>
-        <p:nvPicPr>
-          <p:cNvPr id="47" name="Image 7" descr="videos/machine-learning/03_ridger_regression_gradient_descent/recreated_pptx/build/assets/paren_p047_z.png">    </p:cNvPr>
-          <p:cNvPicPr>
-            <a:picLocks noChangeAspect="1"/>
-          </p:cNvPicPr>
-          <p:nvPr/>
-        </p:nvPicPr>
-        <p:blipFill>
-          <a:blip r:embed="rId8"/>
-          <a:stretch>
-            <a:fillRect/>
-          </a:stretch>
-        </p:blipFill>
-        <p:spPr>
-          <a:xfrm>
-            <a:off x="7582535" y="1003300"/>
-            <a:ext cx="205740" cy="411480"/>
-          </a:xfrm>
-          <a:prstGeom prst="rect">
-            <a:avLst/>
-          </a:prstGeom>
-        </p:spPr>
-      </p:pic>
-      <p:sp>
-        <p:nvSpPr>
-          <p:cNvPr id="48" name="Text 38"/>
+      <p:sp>
+        <p:nvSpPr>
+          <p:cNvPr id="54" name="Shape 52"/>
+          <p:cNvSpPr/>
+          <p:nvPr/>
+        </p:nvSpPr>
+        <p:spPr>
+          <a:xfrm>
+            <a:off x="7595362" y="1016000"/>
+            <a:ext cx="12700" cy="406400"/>
+          </a:xfrm>
+          <a:prstGeom prst="rect">
+            <a:avLst/>
+          </a:prstGeom>
+          <a:solidFill>
+            <a:srgbClr val="909090"/>
+          </a:solidFill>
+          <a:ln/>
+        </p:spPr>
+      </p:sp>
+      <p:sp>
+        <p:nvSpPr>
+          <p:cNvPr id="55" name="Shape 53"/>
+          <p:cNvSpPr/>
+          <p:nvPr/>
+        </p:nvSpPr>
+        <p:spPr>
+          <a:xfrm>
+            <a:off x="7745984" y="1016000"/>
+            <a:ext cx="12700" cy="406400"/>
+          </a:xfrm>
+          <a:prstGeom prst="rect">
+            <a:avLst/>
+          </a:prstGeom>
+          <a:solidFill>
+            <a:srgbClr val="909090"/>
+          </a:solidFill>
+          <a:ln/>
+        </p:spPr>
+      </p:sp>
+      <p:sp>
+        <p:nvSpPr>
+          <p:cNvPr id="56" name="Text 54"/>
           <p:cNvSpPr/>
           <p:nvPr/>
         </p:nvSpPr>
@@ -2593,7 +2721,7 @@
       </p:sp>
       <p:sp>
         <p:nvSpPr>
-          <p:cNvPr id="49" name="Text 39"/>
+          <p:cNvPr id="57" name="Text 55"/>
           <p:cNvSpPr/>
           <p:nvPr/>
         </p:nvSpPr>
@@ -2632,7 +2760,7 @@
       </p:sp>
       <p:sp>
         <p:nvSpPr>
-          <p:cNvPr id="50" name="Text 40"/>
+          <p:cNvPr id="58" name="Text 56"/>
           <p:cNvSpPr/>
           <p:nvPr/>
         </p:nvSpPr>
@@ -2669,33 +2797,49 @@
           </a:p>
         </p:txBody>
       </p:sp>
-      <p:pic>
-        <p:nvPicPr>
-          <p:cNvPr id="51" name="Image 8" descr="videos/machine-learning/03_ridger_regression_gradient_descent/recreated_pptx/build/assets/paren_p047_z.png">    </p:cNvPr>
-          <p:cNvPicPr>
-            <a:picLocks noChangeAspect="1"/>
-          </p:cNvPicPr>
-          <p:nvPr/>
-        </p:nvPicPr>
-        <p:blipFill>
-          <a:blip r:embed="rId9"/>
-          <a:stretch>
-            <a:fillRect/>
-          </a:stretch>
-        </p:blipFill>
-        <p:spPr>
-          <a:xfrm>
-            <a:off x="7875524" y="1003300"/>
-            <a:ext cx="205740" cy="411480"/>
-          </a:xfrm>
-          <a:prstGeom prst="rect">
-            <a:avLst/>
-          </a:prstGeom>
-        </p:spPr>
-      </p:pic>
-      <p:sp>
-        <p:nvSpPr>
-          <p:cNvPr id="52" name="Text 41"/>
+      <p:sp>
+        <p:nvSpPr>
+          <p:cNvPr id="59" name="Shape 57"/>
+          <p:cNvSpPr/>
+          <p:nvPr/>
+        </p:nvSpPr>
+        <p:spPr>
+          <a:xfrm>
+            <a:off x="7892415" y="1016000"/>
+            <a:ext cx="12700" cy="406400"/>
+          </a:xfrm>
+          <a:prstGeom prst="rect">
+            <a:avLst/>
+          </a:prstGeom>
+          <a:solidFill>
+            <a:srgbClr val="909090"/>
+          </a:solidFill>
+          <a:ln/>
+        </p:spPr>
+      </p:sp>
+      <p:sp>
+        <p:nvSpPr>
+          <p:cNvPr id="60" name="Shape 58"/>
+          <p:cNvSpPr/>
+          <p:nvPr/>
+        </p:nvSpPr>
+        <p:spPr>
+          <a:xfrm>
+            <a:off x="8036306" y="1016000"/>
+            <a:ext cx="12700" cy="406400"/>
+          </a:xfrm>
+          <a:prstGeom prst="rect">
+            <a:avLst/>
+          </a:prstGeom>
+          <a:solidFill>
+            <a:srgbClr val="909090"/>
+          </a:solidFill>
+          <a:ln/>
+        </p:spPr>
+      </p:sp>
+      <p:sp>
+        <p:nvSpPr>
+          <p:cNvPr id="61" name="Text 59"/>
           <p:cNvSpPr/>
           <p:nvPr/>
         </p:nvSpPr>
@@ -2734,7 +2878,7 @@
       </p:sp>
       <p:sp>
         <p:nvSpPr>
-          <p:cNvPr id="53" name="Text 42"/>
+          <p:cNvPr id="62" name="Text 60"/>
           <p:cNvSpPr/>
           <p:nvPr/>
         </p:nvSpPr>
@@ -2773,7 +2917,7 @@
       </p:sp>
       <p:sp>
         <p:nvSpPr>
-          <p:cNvPr id="54" name="Text 43"/>
+          <p:cNvPr id="63" name="Text 61"/>
           <p:cNvSpPr/>
           <p:nvPr/>
         </p:nvSpPr>
@@ -2810,33 +2954,49 @@
           </a:p>
         </p:txBody>
       </p:sp>
-      <p:pic>
-        <p:nvPicPr>
-          <p:cNvPr id="55" name="Image 9" descr="videos/machine-learning/03_ridger_regression_gradient_descent/recreated_pptx/build/assets/paren_p047_z.png">    </p:cNvPr>
-          <p:cNvPicPr>
-            <a:picLocks noChangeAspect="1"/>
-          </p:cNvPicPr>
-          <p:nvPr/>
-        </p:nvPicPr>
-        <p:blipFill>
-          <a:blip r:embed="rId10"/>
-          <a:stretch>
-            <a:fillRect/>
-          </a:stretch>
-        </p:blipFill>
-        <p:spPr>
-          <a:xfrm>
-            <a:off x="8154924" y="1003300"/>
-            <a:ext cx="205740" cy="411480"/>
-          </a:xfrm>
-          <a:prstGeom prst="rect">
-            <a:avLst/>
-          </a:prstGeom>
-        </p:spPr>
-      </p:pic>
-      <p:sp>
-        <p:nvSpPr>
-          <p:cNvPr id="56" name="Text 44"/>
+      <p:sp>
+        <p:nvSpPr>
+          <p:cNvPr id="64" name="Shape 62"/>
+          <p:cNvSpPr/>
+          <p:nvPr/>
+        </p:nvSpPr>
+        <p:spPr>
+          <a:xfrm>
+            <a:off x="8166481" y="1016000"/>
+            <a:ext cx="12700" cy="406400"/>
+          </a:xfrm>
+          <a:prstGeom prst="rect">
+            <a:avLst/>
+          </a:prstGeom>
+          <a:solidFill>
+            <a:srgbClr val="909090"/>
+          </a:solidFill>
+          <a:ln/>
+        </p:spPr>
+      </p:sp>
+      <p:sp>
+        <p:nvSpPr>
+          <p:cNvPr id="65" name="Shape 63"/>
+          <p:cNvSpPr/>
+          <p:nvPr/>
+        </p:nvSpPr>
+        <p:spPr>
+          <a:xfrm>
+            <a:off x="8311515" y="1016000"/>
+            <a:ext cx="12700" cy="406400"/>
+          </a:xfrm>
+          <a:prstGeom prst="rect">
+            <a:avLst/>
+          </a:prstGeom>
+          <a:solidFill>
+            <a:srgbClr val="909090"/>
+          </a:solidFill>
+          <a:ln/>
+        </p:spPr>
+      </p:sp>
+      <p:sp>
+        <p:nvSpPr>
+          <p:cNvPr id="66" name="Text 64"/>
           <p:cNvSpPr/>
           <p:nvPr/>
         </p:nvSpPr>
@@ -2875,7 +3035,7 @@
       </p:sp>
       <p:sp>
         <p:nvSpPr>
-          <p:cNvPr id="57" name="Text 45"/>
+          <p:cNvPr id="67" name="Text 65"/>
           <p:cNvSpPr/>
           <p:nvPr/>
         </p:nvSpPr>
@@ -2914,7 +3074,7 @@
       </p:sp>
       <p:sp>
         <p:nvSpPr>
-          <p:cNvPr id="58" name="Text 46"/>
+          <p:cNvPr id="68" name="Text 66"/>
           <p:cNvSpPr/>
           <p:nvPr/>
         </p:nvSpPr>
@@ -2953,7 +3113,7 @@
       </p:sp>
       <p:sp>
         <p:nvSpPr>
-          <p:cNvPr id="59" name="Shape 47"/>
+          <p:cNvPr id="69" name="Shape 67"/>
           <p:cNvSpPr/>
           <p:nvPr/>
         </p:nvSpPr>
@@ -2978,7 +3138,7 @@
       </p:sp>
       <p:sp>
         <p:nvSpPr>
-          <p:cNvPr id="60" name="Text 48"/>
+          <p:cNvPr id="70" name="Text 68"/>
           <p:cNvSpPr/>
           <p:nvPr/>
         </p:nvSpPr>
@@ -3015,33 +3175,49 @@
           </a:p>
         </p:txBody>
       </p:sp>
-      <p:pic>
-        <p:nvPicPr>
-          <p:cNvPr id="61" name="Image 10" descr="videos/machine-learning/03_ridger_regression_gradient_descent/recreated_pptx/build/assets/paren_p047_aug3.png">    </p:cNvPr>
-          <p:cNvPicPr>
-            <a:picLocks noChangeAspect="1"/>
-          </p:cNvPicPr>
-          <p:nvPr/>
-        </p:nvPicPr>
-        <p:blipFill>
-          <a:blip r:embed="rId11"/>
-          <a:stretch>
-            <a:fillRect/>
-          </a:stretch>
-        </p:blipFill>
-        <p:spPr>
-          <a:xfrm>
-            <a:off x="1176655" y="2298700"/>
-            <a:ext cx="193548" cy="577596"/>
-          </a:xfrm>
-          <a:prstGeom prst="rect">
-            <a:avLst/>
-          </a:prstGeom>
-        </p:spPr>
-      </p:pic>
-      <p:sp>
-        <p:nvSpPr>
-          <p:cNvPr id="62" name="Text 49"/>
+      <p:sp>
+        <p:nvSpPr>
+          <p:cNvPr id="71" name="Shape 69"/>
+          <p:cNvSpPr/>
+          <p:nvPr/>
+        </p:nvSpPr>
+        <p:spPr>
+          <a:xfrm>
+            <a:off x="1184529" y="2286000"/>
+            <a:ext cx="12700" cy="584200"/>
+          </a:xfrm>
+          <a:prstGeom prst="rect">
+            <a:avLst/>
+          </a:prstGeom>
+          <a:solidFill>
+            <a:srgbClr val="909090"/>
+          </a:solidFill>
+          <a:ln/>
+        </p:spPr>
+      </p:sp>
+      <p:sp>
+        <p:nvSpPr>
+          <p:cNvPr id="72" name="Shape 70"/>
+          <p:cNvSpPr/>
+          <p:nvPr/>
+        </p:nvSpPr>
+        <p:spPr>
+          <a:xfrm>
+            <a:off x="1342009" y="2286000"/>
+            <a:ext cx="12700" cy="584200"/>
+          </a:xfrm>
+          <a:prstGeom prst="rect">
+            <a:avLst/>
+          </a:prstGeom>
+          <a:solidFill>
+            <a:srgbClr val="909090"/>
+          </a:solidFill>
+          <a:ln/>
+        </p:spPr>
+      </p:sp>
+      <p:sp>
+        <p:nvSpPr>
+          <p:cNvPr id="73" name="Text 71"/>
           <p:cNvSpPr/>
           <p:nvPr/>
         </p:nvSpPr>
@@ -3080,7 +3256,7 @@
       </p:sp>
       <p:sp>
         <p:nvSpPr>
-          <p:cNvPr id="63" name="Text 50"/>
+          <p:cNvPr id="74" name="Text 72"/>
           <p:cNvSpPr/>
           <p:nvPr/>
         </p:nvSpPr>
@@ -3119,7 +3295,7 @@
       </p:sp>
       <p:sp>
         <p:nvSpPr>
-          <p:cNvPr id="64" name="Text 51"/>
+          <p:cNvPr id="75" name="Text 73"/>
           <p:cNvSpPr/>
           <p:nvPr/>
         </p:nvSpPr>
@@ -3158,7 +3334,7 @@
       </p:sp>
       <p:sp>
         <p:nvSpPr>
-          <p:cNvPr id="65" name="Text 52"/>
+          <p:cNvPr id="76" name="Text 74"/>
           <p:cNvSpPr/>
           <p:nvPr/>
         </p:nvSpPr>
@@ -3197,7 +3373,7 @@
       </p:sp>
       <p:sp>
         <p:nvSpPr>
-          <p:cNvPr id="66" name="Text 53"/>
+          <p:cNvPr id="77" name="Text 75"/>
           <p:cNvSpPr/>
           <p:nvPr/>
         </p:nvSpPr>
@@ -3234,33 +3410,49 @@
           </a:p>
         </p:txBody>
       </p:sp>
-      <p:pic>
-        <p:nvPicPr>
-          <p:cNvPr id="67" name="Image 11" descr="videos/machine-learning/03_ridger_regression_gradient_descent/recreated_pptx/build/assets/paren_p047_aug3.png">    </p:cNvPr>
-          <p:cNvPicPr>
-            <a:picLocks noChangeAspect="1"/>
-          </p:cNvPicPr>
-          <p:nvPr/>
-        </p:nvPicPr>
-        <p:blipFill>
-          <a:blip r:embed="rId12"/>
-          <a:stretch>
-            <a:fillRect/>
-          </a:stretch>
-        </p:blipFill>
-        <p:spPr>
-          <a:xfrm>
-            <a:off x="1443355" y="2298700"/>
-            <a:ext cx="193548" cy="577596"/>
-          </a:xfrm>
-          <a:prstGeom prst="rect">
-            <a:avLst/>
-          </a:prstGeom>
-        </p:spPr>
-      </p:pic>
-      <p:sp>
-        <p:nvSpPr>
-          <p:cNvPr id="68" name="Text 54"/>
+      <p:sp>
+        <p:nvSpPr>
+          <p:cNvPr id="78" name="Shape 76"/>
+          <p:cNvSpPr/>
+          <p:nvPr/>
+        </p:nvSpPr>
+        <p:spPr>
+          <a:xfrm>
+            <a:off x="1456182" y="2286000"/>
+            <a:ext cx="12700" cy="584200"/>
+          </a:xfrm>
+          <a:prstGeom prst="rect">
+            <a:avLst/>
+          </a:prstGeom>
+          <a:solidFill>
+            <a:srgbClr val="909090"/>
+          </a:solidFill>
+          <a:ln/>
+        </p:spPr>
+      </p:sp>
+      <p:sp>
+        <p:nvSpPr>
+          <p:cNvPr id="79" name="Shape 77"/>
+          <p:cNvSpPr/>
+          <p:nvPr/>
+        </p:nvSpPr>
+        <p:spPr>
+          <a:xfrm>
+            <a:off x="1601343" y="2286000"/>
+            <a:ext cx="12700" cy="584200"/>
+          </a:xfrm>
+          <a:prstGeom prst="rect">
+            <a:avLst/>
+          </a:prstGeom>
+          <a:solidFill>
+            <a:srgbClr val="909090"/>
+          </a:solidFill>
+          <a:ln/>
+        </p:spPr>
+      </p:sp>
+      <p:sp>
+        <p:nvSpPr>
+          <p:cNvPr id="80" name="Text 78"/>
           <p:cNvSpPr/>
           <p:nvPr/>
         </p:nvSpPr>
@@ -3299,7 +3491,7 @@
       </p:sp>
       <p:sp>
         <p:nvSpPr>
-          <p:cNvPr id="69" name="Text 55"/>
+          <p:cNvPr id="81" name="Text 79"/>
           <p:cNvSpPr/>
           <p:nvPr/>
         </p:nvSpPr>
@@ -3338,7 +3530,7 @@
       </p:sp>
       <p:sp>
         <p:nvSpPr>
-          <p:cNvPr id="70" name="Text 56"/>
+          <p:cNvPr id="82" name="Text 80"/>
           <p:cNvSpPr/>
           <p:nvPr/>
         </p:nvSpPr>
@@ -3377,7 +3569,7 @@
       </p:sp>
       <p:sp>
         <p:nvSpPr>
-          <p:cNvPr id="71" name="Text 57"/>
+          <p:cNvPr id="83" name="Text 81"/>
           <p:cNvSpPr/>
           <p:nvPr/>
         </p:nvSpPr>
@@ -3416,7 +3608,7 @@
       </p:sp>
       <p:sp>
         <p:nvSpPr>
-          <p:cNvPr id="72" name="Text 58"/>
+          <p:cNvPr id="84" name="Text 82"/>
           <p:cNvSpPr/>
           <p:nvPr/>
         </p:nvSpPr>
@@ -3453,33 +3645,49 @@
           </a:p>
         </p:txBody>
       </p:sp>
-      <p:pic>
-        <p:nvPicPr>
-          <p:cNvPr id="73" name="Image 12" descr="videos/machine-learning/03_ridger_regression_gradient_descent/recreated_pptx/build/assets/paren_p047_aug3.png">    </p:cNvPr>
-          <p:cNvPicPr>
-            <a:picLocks noChangeAspect="1"/>
-          </p:cNvPicPr>
-          <p:nvPr/>
-        </p:nvPicPr>
-        <p:blipFill>
-          <a:blip r:embed="rId13"/>
-          <a:stretch>
-            <a:fillRect/>
-          </a:stretch>
-        </p:blipFill>
-        <p:spPr>
-          <a:xfrm>
-            <a:off x="1728597" y="2298700"/>
-            <a:ext cx="193548" cy="577596"/>
-          </a:xfrm>
-          <a:prstGeom prst="rect">
-            <a:avLst/>
-          </a:prstGeom>
-        </p:spPr>
-      </p:pic>
-      <p:sp>
-        <p:nvSpPr>
-          <p:cNvPr id="74" name="Text 59"/>
+      <p:sp>
+        <p:nvSpPr>
+          <p:cNvPr id="85" name="Shape 83"/>
+          <p:cNvSpPr/>
+          <p:nvPr/>
+        </p:nvSpPr>
+        <p:spPr>
+          <a:xfrm>
+            <a:off x="1741297" y="2286000"/>
+            <a:ext cx="12700" cy="584200"/>
+          </a:xfrm>
+          <a:prstGeom prst="rect">
+            <a:avLst/>
+          </a:prstGeom>
+          <a:solidFill>
+            <a:srgbClr val="909090"/>
+          </a:solidFill>
+          <a:ln/>
+        </p:spPr>
+      </p:sp>
+      <p:sp>
+        <p:nvSpPr>
+          <p:cNvPr id="86" name="Shape 84"/>
+          <p:cNvSpPr/>
+          <p:nvPr/>
+        </p:nvSpPr>
+        <p:spPr>
+          <a:xfrm>
+            <a:off x="1892300" y="2286000"/>
+            <a:ext cx="12700" cy="584200"/>
+          </a:xfrm>
+          <a:prstGeom prst="rect">
+            <a:avLst/>
+          </a:prstGeom>
+          <a:solidFill>
+            <a:srgbClr val="909090"/>
+          </a:solidFill>
+          <a:ln/>
+        </p:spPr>
+      </p:sp>
+      <p:sp>
+        <p:nvSpPr>
+          <p:cNvPr id="87" name="Text 85"/>
           <p:cNvSpPr/>
           <p:nvPr/>
         </p:nvSpPr>
@@ -3518,7 +3726,7 @@
       </p:sp>
       <p:sp>
         <p:nvSpPr>
-          <p:cNvPr id="75" name="Text 60"/>
+          <p:cNvPr id="88" name="Text 86"/>
           <p:cNvSpPr/>
           <p:nvPr/>
         </p:nvSpPr>
@@ -3557,7 +3765,7 @@
       </p:sp>
       <p:sp>
         <p:nvSpPr>
-          <p:cNvPr id="76" name="Text 61"/>
+          <p:cNvPr id="89" name="Text 87"/>
           <p:cNvSpPr/>
           <p:nvPr/>
         </p:nvSpPr>
@@ -3596,7 +3804,7 @@
       </p:sp>
       <p:sp>
         <p:nvSpPr>
-          <p:cNvPr id="77" name="Text 62"/>
+          <p:cNvPr id="90" name="Text 88"/>
           <p:cNvSpPr/>
           <p:nvPr/>
         </p:nvSpPr>
@@ -3635,7 +3843,7 @@
       </p:sp>
       <p:sp>
         <p:nvSpPr>
-          <p:cNvPr id="78" name="Text 63"/>
+          <p:cNvPr id="91" name="Text 89"/>
           <p:cNvSpPr/>
           <p:nvPr/>
         </p:nvSpPr>
@@ -3672,33 +3880,49 @@
           </a:p>
         </p:txBody>
       </p:sp>
-      <p:pic>
-        <p:nvPicPr>
-          <p:cNvPr id="79" name="Image 13" descr="videos/machine-learning/03_ridger_regression_gradient_descent/recreated_pptx/build/assets/paren_p047_aug3.png">    </p:cNvPr>
-          <p:cNvPicPr>
-            <a:picLocks noChangeAspect="1"/>
-          </p:cNvPicPr>
-          <p:nvPr/>
-        </p:nvPicPr>
-        <p:blipFill>
-          <a:blip r:embed="rId14"/>
-          <a:stretch>
-            <a:fillRect/>
-          </a:stretch>
-        </p:blipFill>
-        <p:spPr>
-          <a:xfrm>
-            <a:off x="2013966" y="2298700"/>
-            <a:ext cx="193548" cy="577596"/>
-          </a:xfrm>
-          <a:prstGeom prst="rect">
-            <a:avLst/>
-          </a:prstGeom>
-        </p:spPr>
-      </p:pic>
-      <p:sp>
-        <p:nvSpPr>
-          <p:cNvPr id="80" name="Text 64"/>
+      <p:sp>
+        <p:nvSpPr>
+          <p:cNvPr id="92" name="Shape 90"/>
+          <p:cNvSpPr/>
+          <p:nvPr/>
+        </p:nvSpPr>
+        <p:spPr>
+          <a:xfrm>
+            <a:off x="2025523" y="2286000"/>
+            <a:ext cx="12700" cy="584200"/>
+          </a:xfrm>
+          <a:prstGeom prst="rect">
+            <a:avLst/>
+          </a:prstGeom>
+          <a:solidFill>
+            <a:srgbClr val="909090"/>
+          </a:solidFill>
+          <a:ln/>
+        </p:spPr>
+      </p:sp>
+      <p:sp>
+        <p:nvSpPr>
+          <p:cNvPr id="93" name="Shape 91"/>
+          <p:cNvSpPr/>
+          <p:nvPr/>
+        </p:nvSpPr>
+        <p:spPr>
+          <a:xfrm>
+            <a:off x="2175383" y="2286000"/>
+            <a:ext cx="12700" cy="584200"/>
+          </a:xfrm>
+          <a:prstGeom prst="rect">
+            <a:avLst/>
+          </a:prstGeom>
+          <a:solidFill>
+            <a:srgbClr val="909090"/>
+          </a:solidFill>
+          <a:ln/>
+        </p:spPr>
+      </p:sp>
+      <p:sp>
+        <p:nvSpPr>
+          <p:cNvPr id="94" name="Text 92"/>
           <p:cNvSpPr/>
           <p:nvPr/>
         </p:nvSpPr>
@@ -3737,7 +3961,7 @@
       </p:sp>
       <p:sp>
         <p:nvSpPr>
-          <p:cNvPr id="81" name="Text 65"/>
+          <p:cNvPr id="95" name="Text 93"/>
           <p:cNvSpPr/>
           <p:nvPr/>
         </p:nvSpPr>
@@ -3776,7 +4000,7 @@
       </p:sp>
       <p:sp>
         <p:nvSpPr>
-          <p:cNvPr id="82" name="Text 66"/>
+          <p:cNvPr id="96" name="Text 94"/>
           <p:cNvSpPr/>
           <p:nvPr/>
         </p:nvSpPr>
@@ -3815,7 +4039,7 @@
       </p:sp>
       <p:sp>
         <p:nvSpPr>
-          <p:cNvPr id="83" name="Text 67"/>
+          <p:cNvPr id="97" name="Text 95"/>
           <p:cNvSpPr/>
           <p:nvPr/>
         </p:nvSpPr>
@@ -3854,7 +4078,7 @@
       </p:sp>
       <p:sp>
         <p:nvSpPr>
-          <p:cNvPr id="84" name="Text 68"/>
+          <p:cNvPr id="98" name="Text 96"/>
           <p:cNvSpPr/>
           <p:nvPr/>
         </p:nvSpPr>
@@ -3891,33 +4115,49 @@
           </a:p>
         </p:txBody>
       </p:sp>
-      <p:pic>
-        <p:nvPicPr>
-          <p:cNvPr id="85" name="Image 14" descr="videos/machine-learning/03_ridger_regression_gradient_descent/recreated_pptx/build/assets/paren_p047_aug3.png">    </p:cNvPr>
-          <p:cNvPicPr>
-            <a:picLocks noChangeAspect="1"/>
-          </p:cNvPicPr>
-          <p:nvPr/>
-        </p:nvPicPr>
-        <p:blipFill>
-          <a:blip r:embed="rId15"/>
-          <a:stretch>
-            <a:fillRect/>
-          </a:stretch>
-        </p:blipFill>
-        <p:spPr>
-          <a:xfrm>
-            <a:off x="2300097" y="2298700"/>
-            <a:ext cx="193548" cy="577596"/>
-          </a:xfrm>
-          <a:prstGeom prst="rect">
-            <a:avLst/>
-          </a:prstGeom>
-        </p:spPr>
-      </p:pic>
-      <p:sp>
-        <p:nvSpPr>
-          <p:cNvPr id="86" name="Text 69"/>
+      <p:sp>
+        <p:nvSpPr>
+          <p:cNvPr id="99" name="Shape 97"/>
+          <p:cNvSpPr/>
+          <p:nvPr/>
+        </p:nvSpPr>
+        <p:spPr>
+          <a:xfrm>
+            <a:off x="2313559" y="2286000"/>
+            <a:ext cx="12700" cy="584200"/>
+          </a:xfrm>
+          <a:prstGeom prst="rect">
+            <a:avLst/>
+          </a:prstGeom>
+          <a:solidFill>
+            <a:srgbClr val="909090"/>
+          </a:solidFill>
+          <a:ln/>
+        </p:spPr>
+      </p:sp>
+      <p:sp>
+        <p:nvSpPr>
+          <p:cNvPr id="100" name="Shape 98"/>
+          <p:cNvSpPr/>
+          <p:nvPr/>
+        </p:nvSpPr>
+        <p:spPr>
+          <a:xfrm>
+            <a:off x="2462276" y="2286000"/>
+            <a:ext cx="12700" cy="584200"/>
+          </a:xfrm>
+          <a:prstGeom prst="rect">
+            <a:avLst/>
+          </a:prstGeom>
+          <a:solidFill>
+            <a:srgbClr val="909090"/>
+          </a:solidFill>
+          <a:ln/>
+        </p:spPr>
+      </p:sp>
+      <p:sp>
+        <p:nvSpPr>
+          <p:cNvPr id="101" name="Text 99"/>
           <p:cNvSpPr/>
           <p:nvPr/>
         </p:nvSpPr>
@@ -3956,7 +4196,7 @@
       </p:sp>
       <p:sp>
         <p:nvSpPr>
-          <p:cNvPr id="87" name="Text 70"/>
+          <p:cNvPr id="102" name="Text 100"/>
           <p:cNvSpPr/>
           <p:nvPr/>
         </p:nvSpPr>
@@ -3995,7 +4235,7 @@
       </p:sp>
       <p:sp>
         <p:nvSpPr>
-          <p:cNvPr id="88" name="Text 71"/>
+          <p:cNvPr id="103" name="Text 101"/>
           <p:cNvSpPr/>
           <p:nvPr/>
         </p:nvSpPr>
@@ -4034,7 +4274,7 @@
       </p:sp>
       <p:sp>
         <p:nvSpPr>
-          <p:cNvPr id="89" name="Text 72"/>
+          <p:cNvPr id="104" name="Text 102"/>
           <p:cNvSpPr/>
           <p:nvPr/>
         </p:nvSpPr>
@@ -4073,7 +4313,7 @@
       </p:sp>
       <p:sp>
         <p:nvSpPr>
-          <p:cNvPr id="90" name="Text 73"/>
+          <p:cNvPr id="105" name="Text 103"/>
           <p:cNvSpPr/>
           <p:nvPr/>
         </p:nvSpPr>
@@ -4110,33 +4350,49 @@
           </a:p>
         </p:txBody>
       </p:sp>
-      <p:pic>
-        <p:nvPicPr>
-          <p:cNvPr id="91" name="Image 15" descr="videos/machine-learning/03_ridger_regression_gradient_descent/recreated_pptx/build/assets/paren_p047_aug3.png">    </p:cNvPr>
-          <p:cNvPicPr>
-            <a:picLocks noChangeAspect="1"/>
-          </p:cNvPicPr>
-          <p:nvPr/>
-        </p:nvPicPr>
-        <p:blipFill>
-          <a:blip r:embed="rId16"/>
-          <a:stretch>
-            <a:fillRect/>
-          </a:stretch>
-        </p:blipFill>
-        <p:spPr>
-          <a:xfrm>
-            <a:off x="2585847" y="2298700"/>
-            <a:ext cx="193548" cy="577596"/>
-          </a:xfrm>
-          <a:prstGeom prst="rect">
-            <a:avLst/>
-          </a:prstGeom>
-        </p:spPr>
-      </p:pic>
-      <p:sp>
-        <p:nvSpPr>
-          <p:cNvPr id="92" name="Text 74"/>
+      <p:sp>
+        <p:nvSpPr>
+          <p:cNvPr id="106" name="Shape 104"/>
+          <p:cNvSpPr/>
+          <p:nvPr/>
+        </p:nvSpPr>
+        <p:spPr>
+          <a:xfrm>
+            <a:off x="2598801" y="2286000"/>
+            <a:ext cx="12700" cy="584200"/>
+          </a:xfrm>
+          <a:prstGeom prst="rect">
+            <a:avLst/>
+          </a:prstGeom>
+          <a:solidFill>
+            <a:srgbClr val="909090"/>
+          </a:solidFill>
+          <a:ln/>
+        </p:spPr>
+      </p:sp>
+      <p:sp>
+        <p:nvSpPr>
+          <p:cNvPr id="107" name="Shape 105"/>
+          <p:cNvSpPr/>
+          <p:nvPr/>
+        </p:nvSpPr>
+        <p:spPr>
+          <a:xfrm>
+            <a:off x="2742311" y="2286000"/>
+            <a:ext cx="12700" cy="584200"/>
+          </a:xfrm>
+          <a:prstGeom prst="rect">
+            <a:avLst/>
+          </a:prstGeom>
+          <a:solidFill>
+            <a:srgbClr val="909090"/>
+          </a:solidFill>
+          <a:ln/>
+        </p:spPr>
+      </p:sp>
+      <p:sp>
+        <p:nvSpPr>
+          <p:cNvPr id="108" name="Text 106"/>
           <p:cNvSpPr/>
           <p:nvPr/>
         </p:nvSpPr>
@@ -4175,7 +4431,7 @@
       </p:sp>
       <p:sp>
         <p:nvSpPr>
-          <p:cNvPr id="93" name="Text 75"/>
+          <p:cNvPr id="109" name="Text 107"/>
           <p:cNvSpPr/>
           <p:nvPr/>
         </p:nvSpPr>
@@ -4214,7 +4470,7 @@
       </p:sp>
       <p:sp>
         <p:nvSpPr>
-          <p:cNvPr id="94" name="Text 76"/>
+          <p:cNvPr id="110" name="Text 108"/>
           <p:cNvSpPr/>
           <p:nvPr/>
         </p:nvSpPr>
@@ -4253,7 +4509,7 @@
       </p:sp>
       <p:sp>
         <p:nvSpPr>
-          <p:cNvPr id="95" name="Text 77"/>
+          <p:cNvPr id="111" name="Text 109"/>
           <p:cNvSpPr/>
           <p:nvPr/>
         </p:nvSpPr>
@@ -4292,7 +4548,7 @@
       </p:sp>
       <p:sp>
         <p:nvSpPr>
-          <p:cNvPr id="96" name="Text 78"/>
+          <p:cNvPr id="112" name="Text 110"/>
           <p:cNvSpPr/>
           <p:nvPr/>
         </p:nvSpPr>
@@ -4331,7 +4587,7 @@
       </p:sp>
       <p:sp>
         <p:nvSpPr>
-          <p:cNvPr id="97" name="Shape 79"/>
+          <p:cNvPr id="113" name="Shape 111"/>
           <p:cNvSpPr/>
           <p:nvPr/>
         </p:nvSpPr>
@@ -4356,7 +4612,7 @@
       </p:sp>
       <p:sp>
         <p:nvSpPr>
-          <p:cNvPr id="98" name="Text 80"/>
+          <p:cNvPr id="114" name="Text 112"/>
           <p:cNvSpPr/>
           <p:nvPr/>
         </p:nvSpPr>
@@ -4395,26 +4651,26 @@
       </p:sp>
       <p:sp>
         <p:nvSpPr>
-          <p:cNvPr id="99" name="Text 81"/>
-          <p:cNvSpPr/>
-          <p:nvPr/>
-        </p:nvSpPr>
-        <p:spPr>
-          <a:xfrm>
-            <a:off x="4254500" y="1828800"/>
-            <a:ext cx="635000" cy="203200"/>
-          </a:xfrm>
-          <a:prstGeom prst="rect">
-            <a:avLst/>
-          </a:prstGeom>
-          <a:noFill/>
-          <a:ln/>
-        </p:spPr>
-        <p:txBody>
-          <a:bodyPr wrap="square" lIns="0" tIns="0" rIns="0" bIns="0" rtlCol="0" anchor="ctr"/>
-          <a:lstStyle/>
-          <a:p>
-            <a:pPr algn="l" indent="0" marL="0">
+          <p:cNvPr id="115" name="Text 113"/>
+          <p:cNvSpPr/>
+          <p:nvPr/>
+        </p:nvSpPr>
+        <p:spPr>
+          <a:xfrm>
+            <a:off x="4191000" y="1860550"/>
+            <a:ext cx="152400" cy="177800"/>
+          </a:xfrm>
+          <a:prstGeom prst="rect">
+            <a:avLst/>
+          </a:prstGeom>
+          <a:noFill/>
+          <a:ln/>
+        </p:spPr>
+        <p:txBody>
+          <a:bodyPr wrap="square" lIns="0" tIns="0" rIns="0" bIns="0" rtlCol="0" anchor="ctr"/>
+          <a:lstStyle/>
+          <a:p>
+            <a:pPr algn="ctr" indent="0" marL="0">
               <a:buNone/>
             </a:pPr>
             <a:r>
@@ -4426,45 +4682,179 @@
                 <a:ea typeface="Times New Roman" pitchFamily="34" charset="-122"/>
                 <a:cs typeface="Times New Roman" pitchFamily="34" charset="-120"/>
               </a:rPr>
-              <a:t>(1  0  0)</a:t>
+              <a:t>1</a:t>
             </a:r>
             <a:endParaRPr lang="en-US" sz="1300" dirty="0"/>
           </a:p>
         </p:txBody>
       </p:sp>
-      <p:pic>
-        <p:nvPicPr>
-          <p:cNvPr id="100" name="Image 16" descr="videos/machine-learning/03_ridger_regression_gradient_descent/recreated_pptx/build/assets/paren_p047_stack.png">    </p:cNvPr>
-          <p:cNvPicPr>
-            <a:picLocks noChangeAspect="1"/>
-          </p:cNvPicPr>
-          <p:nvPr/>
-        </p:nvPicPr>
-        <p:blipFill>
-          <a:blip r:embed="rId17"/>
-          <a:stretch>
-            <a:fillRect/>
-          </a:stretch>
-        </p:blipFill>
-        <p:spPr>
-          <a:xfrm>
-            <a:off x="4927600" y="1905000"/>
-            <a:ext cx="231648" cy="501396"/>
-          </a:xfrm>
-          <a:prstGeom prst="rect">
-            <a:avLst/>
-          </a:prstGeom>
-        </p:spPr>
-      </p:pic>
-      <p:sp>
-        <p:nvSpPr>
-          <p:cNvPr id="101" name="Text 82"/>
-          <p:cNvSpPr/>
-          <p:nvPr/>
-        </p:nvSpPr>
-        <p:spPr>
-          <a:xfrm>
-            <a:off x="4940300" y="1873250"/>
+      <p:sp>
+        <p:nvSpPr>
+          <p:cNvPr id="116" name="Text 114"/>
+          <p:cNvSpPr/>
+          <p:nvPr/>
+        </p:nvSpPr>
+        <p:spPr>
+          <a:xfrm>
+            <a:off x="4413250" y="1860550"/>
+            <a:ext cx="152400" cy="177800"/>
+          </a:xfrm>
+          <a:prstGeom prst="rect">
+            <a:avLst/>
+          </a:prstGeom>
+          <a:noFill/>
+          <a:ln/>
+        </p:spPr>
+        <p:txBody>
+          <a:bodyPr wrap="square" lIns="0" tIns="0" rIns="0" bIns="0" rtlCol="0" anchor="ctr"/>
+          <a:lstStyle/>
+          <a:p>
+            <a:pPr algn="ctr" indent="0" marL="0">
+              <a:buNone/>
+            </a:pPr>
+            <a:r>
+              <a:rPr lang="en-US" sz="1300" dirty="0">
+                <a:solidFill>
+                  <a:srgbClr val="1A1A99"/>
+                </a:solidFill>
+                <a:latin typeface="Times New Roman" pitchFamily="34" charset="0"/>
+                <a:ea typeface="Times New Roman" pitchFamily="34" charset="-122"/>
+                <a:cs typeface="Times New Roman" pitchFamily="34" charset="-120"/>
+              </a:rPr>
+              <a:t>0</a:t>
+            </a:r>
+            <a:endParaRPr lang="en-US" sz="1300" dirty="0"/>
+          </a:p>
+        </p:txBody>
+      </p:sp>
+      <p:sp>
+        <p:nvSpPr>
+          <p:cNvPr id="117" name="Text 115"/>
+          <p:cNvSpPr/>
+          <p:nvPr/>
+        </p:nvSpPr>
+        <p:spPr>
+          <a:xfrm>
+            <a:off x="4616450" y="1860550"/>
+            <a:ext cx="152400" cy="177800"/>
+          </a:xfrm>
+          <a:prstGeom prst="rect">
+            <a:avLst/>
+          </a:prstGeom>
+          <a:noFill/>
+          <a:ln/>
+        </p:spPr>
+        <p:txBody>
+          <a:bodyPr wrap="square" lIns="0" tIns="0" rIns="0" bIns="0" rtlCol="0" anchor="ctr"/>
+          <a:lstStyle/>
+          <a:p>
+            <a:pPr algn="ctr" indent="0" marL="0">
+              <a:buNone/>
+            </a:pPr>
+            <a:r>
+              <a:rPr lang="en-US" sz="1300" dirty="0">
+                <a:solidFill>
+                  <a:srgbClr val="1A1A99"/>
+                </a:solidFill>
+                <a:latin typeface="Times New Roman" pitchFamily="34" charset="0"/>
+                <a:ea typeface="Times New Roman" pitchFamily="34" charset="-122"/>
+                <a:cs typeface="Times New Roman" pitchFamily="34" charset="-120"/>
+              </a:rPr>
+              <a:t>0</a:t>
+            </a:r>
+            <a:endParaRPr lang="en-US" sz="1300" dirty="0"/>
+          </a:p>
+        </p:txBody>
+      </p:sp>
+      <p:sp>
+        <p:nvSpPr>
+          <p:cNvPr id="118" name="Shape 116"/>
+          <p:cNvSpPr/>
+          <p:nvPr/>
+        </p:nvSpPr>
+        <p:spPr>
+          <a:xfrm>
+            <a:off x="4837430" y="1841500"/>
+            <a:ext cx="12700" cy="609600"/>
+          </a:xfrm>
+          <a:prstGeom prst="rect">
+            <a:avLst/>
+          </a:prstGeom>
+          <a:solidFill>
+            <a:srgbClr val="A6A6A6"/>
+          </a:solidFill>
+          <a:ln/>
+        </p:spPr>
+      </p:sp>
+      <p:sp>
+        <p:nvSpPr>
+          <p:cNvPr id="119" name="Shape 117"/>
+          <p:cNvSpPr/>
+          <p:nvPr/>
+        </p:nvSpPr>
+        <p:spPr>
+          <a:xfrm>
+            <a:off x="5130165" y="1841500"/>
+            <a:ext cx="12700" cy="609600"/>
+          </a:xfrm>
+          <a:prstGeom prst="rect">
+            <a:avLst/>
+          </a:prstGeom>
+          <a:solidFill>
+            <a:srgbClr val="A6A6A6"/>
+          </a:solidFill>
+          <a:ln/>
+        </p:spPr>
+      </p:sp>
+      <p:sp>
+        <p:nvSpPr>
+          <p:cNvPr id="120" name="Shape 118"/>
+          <p:cNvSpPr/>
+          <p:nvPr/>
+        </p:nvSpPr>
+        <p:spPr>
+          <a:xfrm>
+            <a:off x="4191000" y="1866900"/>
+            <a:ext cx="12700" cy="165100"/>
+          </a:xfrm>
+          <a:prstGeom prst="rect">
+            <a:avLst/>
+          </a:prstGeom>
+          <a:solidFill>
+            <a:srgbClr val="A6A6A6"/>
+          </a:solidFill>
+          <a:ln/>
+        </p:spPr>
+      </p:sp>
+      <p:sp>
+        <p:nvSpPr>
+          <p:cNvPr id="121" name="Shape 119"/>
+          <p:cNvSpPr/>
+          <p:nvPr/>
+        </p:nvSpPr>
+        <p:spPr>
+          <a:xfrm>
+            <a:off x="4800600" y="1879600"/>
+            <a:ext cx="12700" cy="152400"/>
+          </a:xfrm>
+          <a:prstGeom prst="rect">
+            <a:avLst/>
+          </a:prstGeom>
+          <a:solidFill>
+            <a:srgbClr val="A6A6A6"/>
+          </a:solidFill>
+          <a:ln/>
+        </p:spPr>
+      </p:sp>
+      <p:sp>
+        <p:nvSpPr>
+          <p:cNvPr id="122" name="Text 120"/>
+          <p:cNvSpPr/>
+          <p:nvPr/>
+        </p:nvSpPr>
+        <p:spPr>
+          <a:xfrm>
+            <a:off x="4914900" y="1873250"/>
             <a:ext cx="203200" cy="152400"/>
           </a:xfrm>
           <a:prstGeom prst="rect">
@@ -4497,13 +4887,13 @@
       </p:sp>
       <p:sp>
         <p:nvSpPr>
-          <p:cNvPr id="102" name="Text 83"/>
-          <p:cNvSpPr/>
-          <p:nvPr/>
-        </p:nvSpPr>
-        <p:spPr>
-          <a:xfrm>
-            <a:off x="4940300" y="2044700"/>
+          <p:cNvPr id="123" name="Text 121"/>
+          <p:cNvSpPr/>
+          <p:nvPr/>
+        </p:nvSpPr>
+        <p:spPr>
+          <a:xfrm>
+            <a:off x="4914900" y="2044700"/>
             <a:ext cx="203200" cy="152400"/>
           </a:xfrm>
           <a:prstGeom prst="rect">
@@ -4536,13 +4926,13 @@
       </p:sp>
       <p:sp>
         <p:nvSpPr>
-          <p:cNvPr id="103" name="Text 84"/>
-          <p:cNvSpPr/>
-          <p:nvPr/>
-        </p:nvSpPr>
-        <p:spPr>
-          <a:xfrm>
-            <a:off x="4940300" y="2260600"/>
+          <p:cNvPr id="124" name="Text 122"/>
+          <p:cNvSpPr/>
+          <p:nvPr/>
+        </p:nvSpPr>
+        <p:spPr>
+          <a:xfrm>
+            <a:off x="4914900" y="2260600"/>
             <a:ext cx="203200" cy="152400"/>
           </a:xfrm>
           <a:prstGeom prst="rect">
@@ -4575,7 +4965,7 @@
       </p:sp>
       <p:sp>
         <p:nvSpPr>
-          <p:cNvPr id="104" name="Text 85"/>
+          <p:cNvPr id="125" name="Text 123"/>
           <p:cNvSpPr/>
           <p:nvPr/>
         </p:nvSpPr>
@@ -4614,7 +5004,7 @@
       </p:sp>
       <p:sp>
         <p:nvSpPr>
-          <p:cNvPr id="105" name="Text 86"/>
+          <p:cNvPr id="126" name="Text 124"/>
           <p:cNvSpPr/>
           <p:nvPr/>
         </p:nvSpPr>
@@ -4653,7 +5043,7 @@
       </p:sp>
       <p:sp>
         <p:nvSpPr>
-          <p:cNvPr id="106" name="Text 87"/>
+          <p:cNvPr id="127" name="Text 125"/>
           <p:cNvSpPr/>
           <p:nvPr/>
         </p:nvSpPr>
@@ -4692,7 +5082,7 @@
       </p:sp>
       <p:sp>
         <p:nvSpPr>
-          <p:cNvPr id="107" name="Shape 88"/>
+          <p:cNvPr id="128" name="Shape 126"/>
           <p:cNvSpPr/>
           <p:nvPr/>
         </p:nvSpPr>
@@ -4717,7 +5107,7 @@
       </p:sp>
       <p:sp>
         <p:nvSpPr>
-          <p:cNvPr id="108" name="Text 89"/>
+          <p:cNvPr id="129" name="Text 127"/>
           <p:cNvSpPr/>
           <p:nvPr/>
         </p:nvSpPr>
@@ -4756,26 +5146,26 @@
       </p:sp>
       <p:sp>
         <p:nvSpPr>
-          <p:cNvPr id="109" name="Text 90"/>
-          <p:cNvSpPr/>
-          <p:nvPr/>
-        </p:nvSpPr>
-        <p:spPr>
-          <a:xfrm>
-            <a:off x="4254500" y="2705100"/>
-            <a:ext cx="635000" cy="203200"/>
-          </a:xfrm>
-          <a:prstGeom prst="rect">
-            <a:avLst/>
-          </a:prstGeom>
-          <a:noFill/>
-          <a:ln/>
-        </p:spPr>
-        <p:txBody>
-          <a:bodyPr wrap="square" lIns="0" tIns="0" rIns="0" bIns="0" rtlCol="0" anchor="ctr"/>
-          <a:lstStyle/>
-          <a:p>
-            <a:pPr algn="l" indent="0" marL="0">
+          <p:cNvPr id="130" name="Text 128"/>
+          <p:cNvSpPr/>
+          <p:nvPr/>
+        </p:nvSpPr>
+        <p:spPr>
+          <a:xfrm>
+            <a:off x="4191000" y="2736850"/>
+            <a:ext cx="152400" cy="177800"/>
+          </a:xfrm>
+          <a:prstGeom prst="rect">
+            <a:avLst/>
+          </a:prstGeom>
+          <a:noFill/>
+          <a:ln/>
+        </p:spPr>
+        <p:txBody>
+          <a:bodyPr wrap="square" lIns="0" tIns="0" rIns="0" bIns="0" rtlCol="0" anchor="ctr"/>
+          <a:lstStyle/>
+          <a:p>
+            <a:pPr algn="ctr" indent="0" marL="0">
               <a:buNone/>
             </a:pPr>
             <a:r>
@@ -4787,45 +5177,179 @@
                 <a:ea typeface="Times New Roman" pitchFamily="34" charset="-122"/>
                 <a:cs typeface="Times New Roman" pitchFamily="34" charset="-120"/>
               </a:rPr>
-              <a:t>(1  7  6)</a:t>
+              <a:t>1</a:t>
             </a:r>
             <a:endParaRPr lang="en-US" sz="1300" dirty="0"/>
           </a:p>
         </p:txBody>
       </p:sp>
-      <p:pic>
-        <p:nvPicPr>
-          <p:cNvPr id="110" name="Image 17" descr="videos/machine-learning/03_ridger_regression_gradient_descent/recreated_pptx/build/assets/paren_p047_stack.png">    </p:cNvPr>
-          <p:cNvPicPr>
-            <a:picLocks noChangeAspect="1"/>
-          </p:cNvPicPr>
-          <p:nvPr/>
-        </p:nvPicPr>
-        <p:blipFill>
-          <a:blip r:embed="rId18"/>
-          <a:stretch>
-            <a:fillRect/>
-          </a:stretch>
-        </p:blipFill>
-        <p:spPr>
-          <a:xfrm>
-            <a:off x="4927600" y="2781300"/>
-            <a:ext cx="231648" cy="501396"/>
-          </a:xfrm>
-          <a:prstGeom prst="rect">
-            <a:avLst/>
-          </a:prstGeom>
-        </p:spPr>
-      </p:pic>
-      <p:sp>
-        <p:nvSpPr>
-          <p:cNvPr id="111" name="Text 91"/>
-          <p:cNvSpPr/>
-          <p:nvPr/>
-        </p:nvSpPr>
-        <p:spPr>
-          <a:xfrm>
-            <a:off x="4940300" y="2749550"/>
+      <p:sp>
+        <p:nvSpPr>
+          <p:cNvPr id="131" name="Text 129"/>
+          <p:cNvSpPr/>
+          <p:nvPr/>
+        </p:nvSpPr>
+        <p:spPr>
+          <a:xfrm>
+            <a:off x="4413250" y="2736850"/>
+            <a:ext cx="152400" cy="177800"/>
+          </a:xfrm>
+          <a:prstGeom prst="rect">
+            <a:avLst/>
+          </a:prstGeom>
+          <a:noFill/>
+          <a:ln/>
+        </p:spPr>
+        <p:txBody>
+          <a:bodyPr wrap="square" lIns="0" tIns="0" rIns="0" bIns="0" rtlCol="0" anchor="ctr"/>
+          <a:lstStyle/>
+          <a:p>
+            <a:pPr algn="ctr" indent="0" marL="0">
+              <a:buNone/>
+            </a:pPr>
+            <a:r>
+              <a:rPr lang="en-US" sz="1300" dirty="0">
+                <a:solidFill>
+                  <a:srgbClr val="1A1A99"/>
+                </a:solidFill>
+                <a:latin typeface="Times New Roman" pitchFamily="34" charset="0"/>
+                <a:ea typeface="Times New Roman" pitchFamily="34" charset="-122"/>
+                <a:cs typeface="Times New Roman" pitchFamily="34" charset="-120"/>
+              </a:rPr>
+              <a:t>7</a:t>
+            </a:r>
+            <a:endParaRPr lang="en-US" sz="1300" dirty="0"/>
+          </a:p>
+        </p:txBody>
+      </p:sp>
+      <p:sp>
+        <p:nvSpPr>
+          <p:cNvPr id="132" name="Text 130"/>
+          <p:cNvSpPr/>
+          <p:nvPr/>
+        </p:nvSpPr>
+        <p:spPr>
+          <a:xfrm>
+            <a:off x="4616450" y="2736850"/>
+            <a:ext cx="152400" cy="177800"/>
+          </a:xfrm>
+          <a:prstGeom prst="rect">
+            <a:avLst/>
+          </a:prstGeom>
+          <a:noFill/>
+          <a:ln/>
+        </p:spPr>
+        <p:txBody>
+          <a:bodyPr wrap="square" lIns="0" tIns="0" rIns="0" bIns="0" rtlCol="0" anchor="ctr"/>
+          <a:lstStyle/>
+          <a:p>
+            <a:pPr algn="ctr" indent="0" marL="0">
+              <a:buNone/>
+            </a:pPr>
+            <a:r>
+              <a:rPr lang="en-US" sz="1300" dirty="0">
+                <a:solidFill>
+                  <a:srgbClr val="1A1A99"/>
+                </a:solidFill>
+                <a:latin typeface="Times New Roman" pitchFamily="34" charset="0"/>
+                <a:ea typeface="Times New Roman" pitchFamily="34" charset="-122"/>
+                <a:cs typeface="Times New Roman" pitchFamily="34" charset="-120"/>
+              </a:rPr>
+              <a:t>6</a:t>
+            </a:r>
+            <a:endParaRPr lang="en-US" sz="1300" dirty="0"/>
+          </a:p>
+        </p:txBody>
+      </p:sp>
+      <p:sp>
+        <p:nvSpPr>
+          <p:cNvPr id="133" name="Shape 131"/>
+          <p:cNvSpPr/>
+          <p:nvPr/>
+        </p:nvSpPr>
+        <p:spPr>
+          <a:xfrm>
+            <a:off x="4837430" y="2717800"/>
+            <a:ext cx="12700" cy="609600"/>
+          </a:xfrm>
+          <a:prstGeom prst="rect">
+            <a:avLst/>
+          </a:prstGeom>
+          <a:solidFill>
+            <a:srgbClr val="A6A6A6"/>
+          </a:solidFill>
+          <a:ln/>
+        </p:spPr>
+      </p:sp>
+      <p:sp>
+        <p:nvSpPr>
+          <p:cNvPr id="134" name="Shape 132"/>
+          <p:cNvSpPr/>
+          <p:nvPr/>
+        </p:nvSpPr>
+        <p:spPr>
+          <a:xfrm>
+            <a:off x="5130165" y="2717800"/>
+            <a:ext cx="12700" cy="609600"/>
+          </a:xfrm>
+          <a:prstGeom prst="rect">
+            <a:avLst/>
+          </a:prstGeom>
+          <a:solidFill>
+            <a:srgbClr val="A6A6A6"/>
+          </a:solidFill>
+          <a:ln/>
+        </p:spPr>
+      </p:sp>
+      <p:sp>
+        <p:nvSpPr>
+          <p:cNvPr id="135" name="Shape 133"/>
+          <p:cNvSpPr/>
+          <p:nvPr/>
+        </p:nvSpPr>
+        <p:spPr>
+          <a:xfrm>
+            <a:off x="4191000" y="2743200"/>
+            <a:ext cx="12700" cy="165100"/>
+          </a:xfrm>
+          <a:prstGeom prst="rect">
+            <a:avLst/>
+          </a:prstGeom>
+          <a:solidFill>
+            <a:srgbClr val="A6A6A6"/>
+          </a:solidFill>
+          <a:ln/>
+        </p:spPr>
+      </p:sp>
+      <p:sp>
+        <p:nvSpPr>
+          <p:cNvPr id="136" name="Shape 134"/>
+          <p:cNvSpPr/>
+          <p:nvPr/>
+        </p:nvSpPr>
+        <p:spPr>
+          <a:xfrm>
+            <a:off x="4800600" y="2755900"/>
+            <a:ext cx="12700" cy="152400"/>
+          </a:xfrm>
+          <a:prstGeom prst="rect">
+            <a:avLst/>
+          </a:prstGeom>
+          <a:solidFill>
+            <a:srgbClr val="A6A6A6"/>
+          </a:solidFill>
+          <a:ln/>
+        </p:spPr>
+      </p:sp>
+      <p:sp>
+        <p:nvSpPr>
+          <p:cNvPr id="137" name="Text 135"/>
+          <p:cNvSpPr/>
+          <p:nvPr/>
+        </p:nvSpPr>
+        <p:spPr>
+          <a:xfrm>
+            <a:off x="4914900" y="2749550"/>
             <a:ext cx="203200" cy="152400"/>
           </a:xfrm>
           <a:prstGeom prst="rect">
@@ -4858,13 +5382,13 @@
       </p:sp>
       <p:sp>
         <p:nvSpPr>
-          <p:cNvPr id="112" name="Text 92"/>
-          <p:cNvSpPr/>
-          <p:nvPr/>
-        </p:nvSpPr>
-        <p:spPr>
-          <a:xfrm>
-            <a:off x="4940300" y="2921000"/>
+          <p:cNvPr id="138" name="Text 136"/>
+          <p:cNvSpPr/>
+          <p:nvPr/>
+        </p:nvSpPr>
+        <p:spPr>
+          <a:xfrm>
+            <a:off x="4914900" y="2921000"/>
             <a:ext cx="203200" cy="152400"/>
           </a:xfrm>
           <a:prstGeom prst="rect">
@@ -4897,13 +5421,13 @@
       </p:sp>
       <p:sp>
         <p:nvSpPr>
-          <p:cNvPr id="113" name="Text 93"/>
-          <p:cNvSpPr/>
-          <p:nvPr/>
-        </p:nvSpPr>
-        <p:spPr>
-          <a:xfrm>
-            <a:off x="4940300" y="3136900"/>
+          <p:cNvPr id="139" name="Text 137"/>
+          <p:cNvSpPr/>
+          <p:nvPr/>
+        </p:nvSpPr>
+        <p:spPr>
+          <a:xfrm>
+            <a:off x="4914900" y="3136900"/>
             <a:ext cx="203200" cy="152400"/>
           </a:xfrm>
           <a:prstGeom prst="rect">
@@ -4936,7 +5460,7 @@
       </p:sp>
       <p:sp>
         <p:nvSpPr>
-          <p:cNvPr id="114" name="Text 94"/>
+          <p:cNvPr id="140" name="Text 138"/>
           <p:cNvSpPr/>
           <p:nvPr/>
         </p:nvSpPr>
@@ -4975,7 +5499,7 @@
       </p:sp>
       <p:sp>
         <p:nvSpPr>
-          <p:cNvPr id="115" name="Text 95"/>
+          <p:cNvPr id="141" name="Text 139"/>
           <p:cNvSpPr/>
           <p:nvPr/>
         </p:nvSpPr>
@@ -5014,7 +5538,7 @@
       </p:sp>
       <p:sp>
         <p:nvSpPr>
-          <p:cNvPr id="116" name="Text 96"/>
+          <p:cNvPr id="142" name="Text 140"/>
           <p:cNvSpPr/>
           <p:nvPr/>
         </p:nvSpPr>
@@ -5053,7 +5577,7 @@
       </p:sp>
       <p:sp>
         <p:nvSpPr>
-          <p:cNvPr id="117" name="Shape 97"/>
+          <p:cNvPr id="143" name="Shape 141"/>
           <p:cNvSpPr/>
           <p:nvPr/>
         </p:nvSpPr>
@@ -5078,7 +5602,7 @@
       </p:sp>
       <p:sp>
         <p:nvSpPr>
-          <p:cNvPr id="118" name="Text 98"/>
+          <p:cNvPr id="144" name="Text 142"/>
           <p:cNvSpPr/>
           <p:nvPr/>
         </p:nvSpPr>
@@ -5117,26 +5641,26 @@
       </p:sp>
       <p:sp>
         <p:nvSpPr>
-          <p:cNvPr id="119" name="Text 99"/>
-          <p:cNvSpPr/>
-          <p:nvPr/>
-        </p:nvSpPr>
-        <p:spPr>
-          <a:xfrm>
-            <a:off x="4254500" y="3543300"/>
-            <a:ext cx="635000" cy="203200"/>
-          </a:xfrm>
-          <a:prstGeom prst="rect">
-            <a:avLst/>
-          </a:prstGeom>
-          <a:noFill/>
-          <a:ln/>
-        </p:spPr>
-        <p:txBody>
-          <a:bodyPr wrap="square" lIns="0" tIns="0" rIns="0" bIns="0" rtlCol="0" anchor="ctr"/>
-          <a:lstStyle/>
-          <a:p>
-            <a:pPr algn="l" indent="0" marL="0">
+          <p:cNvPr id="145" name="Text 143"/>
+          <p:cNvSpPr/>
+          <p:nvPr/>
+        </p:nvSpPr>
+        <p:spPr>
+          <a:xfrm>
+            <a:off x="4191000" y="3575050"/>
+            <a:ext cx="152400" cy="177800"/>
+          </a:xfrm>
+          <a:prstGeom prst="rect">
+            <a:avLst/>
+          </a:prstGeom>
+          <a:noFill/>
+          <a:ln/>
+        </p:spPr>
+        <p:txBody>
+          <a:bodyPr wrap="square" lIns="0" tIns="0" rIns="0" bIns="0" rtlCol="0" anchor="ctr"/>
+          <a:lstStyle/>
+          <a:p>
+            <a:pPr algn="ctr" indent="0" marL="0">
               <a:buNone/>
             </a:pPr>
             <a:r>
@@ -5148,45 +5672,179 @@
                 <a:ea typeface="Times New Roman" pitchFamily="34" charset="-122"/>
                 <a:cs typeface="Times New Roman" pitchFamily="34" charset="-120"/>
               </a:rPr>
-              <a:t>(1  3  2)</a:t>
+              <a:t>1</a:t>
             </a:r>
             <a:endParaRPr lang="en-US" sz="1300" dirty="0"/>
           </a:p>
         </p:txBody>
       </p:sp>
-      <p:pic>
-        <p:nvPicPr>
-          <p:cNvPr id="120" name="Image 18" descr="videos/machine-learning/03_ridger_regression_gradient_descent/recreated_pptx/build/assets/paren_p047_stack.png">    </p:cNvPr>
-          <p:cNvPicPr>
-            <a:picLocks noChangeAspect="1"/>
-          </p:cNvPicPr>
-          <p:nvPr/>
-        </p:nvPicPr>
-        <p:blipFill>
-          <a:blip r:embed="rId19"/>
-          <a:stretch>
-            <a:fillRect/>
-          </a:stretch>
-        </p:blipFill>
-        <p:spPr>
-          <a:xfrm>
-            <a:off x="4927600" y="3619500"/>
-            <a:ext cx="231648" cy="501396"/>
-          </a:xfrm>
-          <a:prstGeom prst="rect">
-            <a:avLst/>
-          </a:prstGeom>
-        </p:spPr>
-      </p:pic>
-      <p:sp>
-        <p:nvSpPr>
-          <p:cNvPr id="121" name="Text 100"/>
-          <p:cNvSpPr/>
-          <p:nvPr/>
-        </p:nvSpPr>
-        <p:spPr>
-          <a:xfrm>
-            <a:off x="4940300" y="3587750"/>
+      <p:sp>
+        <p:nvSpPr>
+          <p:cNvPr id="146" name="Text 144"/>
+          <p:cNvSpPr/>
+          <p:nvPr/>
+        </p:nvSpPr>
+        <p:spPr>
+          <a:xfrm>
+            <a:off x="4413250" y="3575050"/>
+            <a:ext cx="152400" cy="177800"/>
+          </a:xfrm>
+          <a:prstGeom prst="rect">
+            <a:avLst/>
+          </a:prstGeom>
+          <a:noFill/>
+          <a:ln/>
+        </p:spPr>
+        <p:txBody>
+          <a:bodyPr wrap="square" lIns="0" tIns="0" rIns="0" bIns="0" rtlCol="0" anchor="ctr"/>
+          <a:lstStyle/>
+          <a:p>
+            <a:pPr algn="ctr" indent="0" marL="0">
+              <a:buNone/>
+            </a:pPr>
+            <a:r>
+              <a:rPr lang="en-US" sz="1300" dirty="0">
+                <a:solidFill>
+                  <a:srgbClr val="1A1A99"/>
+                </a:solidFill>
+                <a:latin typeface="Times New Roman" pitchFamily="34" charset="0"/>
+                <a:ea typeface="Times New Roman" pitchFamily="34" charset="-122"/>
+                <a:cs typeface="Times New Roman" pitchFamily="34" charset="-120"/>
+              </a:rPr>
+              <a:t>3</a:t>
+            </a:r>
+            <a:endParaRPr lang="en-US" sz="1300" dirty="0"/>
+          </a:p>
+        </p:txBody>
+      </p:sp>
+      <p:sp>
+        <p:nvSpPr>
+          <p:cNvPr id="147" name="Text 145"/>
+          <p:cNvSpPr/>
+          <p:nvPr/>
+        </p:nvSpPr>
+        <p:spPr>
+          <a:xfrm>
+            <a:off x="4616450" y="3575050"/>
+            <a:ext cx="152400" cy="177800"/>
+          </a:xfrm>
+          <a:prstGeom prst="rect">
+            <a:avLst/>
+          </a:prstGeom>
+          <a:noFill/>
+          <a:ln/>
+        </p:spPr>
+        <p:txBody>
+          <a:bodyPr wrap="square" lIns="0" tIns="0" rIns="0" bIns="0" rtlCol="0" anchor="ctr"/>
+          <a:lstStyle/>
+          <a:p>
+            <a:pPr algn="ctr" indent="0" marL="0">
+              <a:buNone/>
+            </a:pPr>
+            <a:r>
+              <a:rPr lang="en-US" sz="1300" dirty="0">
+                <a:solidFill>
+                  <a:srgbClr val="1A1A99"/>
+                </a:solidFill>
+                <a:latin typeface="Times New Roman" pitchFamily="34" charset="0"/>
+                <a:ea typeface="Times New Roman" pitchFamily="34" charset="-122"/>
+                <a:cs typeface="Times New Roman" pitchFamily="34" charset="-120"/>
+              </a:rPr>
+              <a:t>2</a:t>
+            </a:r>
+            <a:endParaRPr lang="en-US" sz="1300" dirty="0"/>
+          </a:p>
+        </p:txBody>
+      </p:sp>
+      <p:sp>
+        <p:nvSpPr>
+          <p:cNvPr id="148" name="Shape 146"/>
+          <p:cNvSpPr/>
+          <p:nvPr/>
+        </p:nvSpPr>
+        <p:spPr>
+          <a:xfrm>
+            <a:off x="4837430" y="3556000"/>
+            <a:ext cx="12700" cy="596900"/>
+          </a:xfrm>
+          <a:prstGeom prst="rect">
+            <a:avLst/>
+          </a:prstGeom>
+          <a:solidFill>
+            <a:srgbClr val="A6A6A6"/>
+          </a:solidFill>
+          <a:ln/>
+        </p:spPr>
+      </p:sp>
+      <p:sp>
+        <p:nvSpPr>
+          <p:cNvPr id="149" name="Shape 147"/>
+          <p:cNvSpPr/>
+          <p:nvPr/>
+        </p:nvSpPr>
+        <p:spPr>
+          <a:xfrm>
+            <a:off x="5130165" y="3556000"/>
+            <a:ext cx="12700" cy="596900"/>
+          </a:xfrm>
+          <a:prstGeom prst="rect">
+            <a:avLst/>
+          </a:prstGeom>
+          <a:solidFill>
+            <a:srgbClr val="A6A6A6"/>
+          </a:solidFill>
+          <a:ln/>
+        </p:spPr>
+      </p:sp>
+      <p:sp>
+        <p:nvSpPr>
+          <p:cNvPr id="150" name="Shape 148"/>
+          <p:cNvSpPr/>
+          <p:nvPr/>
+        </p:nvSpPr>
+        <p:spPr>
+          <a:xfrm>
+            <a:off x="4191000" y="3581400"/>
+            <a:ext cx="12700" cy="165100"/>
+          </a:xfrm>
+          <a:prstGeom prst="rect">
+            <a:avLst/>
+          </a:prstGeom>
+          <a:solidFill>
+            <a:srgbClr val="A6A6A6"/>
+          </a:solidFill>
+          <a:ln/>
+        </p:spPr>
+      </p:sp>
+      <p:sp>
+        <p:nvSpPr>
+          <p:cNvPr id="151" name="Shape 149"/>
+          <p:cNvSpPr/>
+          <p:nvPr/>
+        </p:nvSpPr>
+        <p:spPr>
+          <a:xfrm>
+            <a:off x="4800600" y="3594100"/>
+            <a:ext cx="12700" cy="152400"/>
+          </a:xfrm>
+          <a:prstGeom prst="rect">
+            <a:avLst/>
+          </a:prstGeom>
+          <a:solidFill>
+            <a:srgbClr val="A6A6A6"/>
+          </a:solidFill>
+          <a:ln/>
+        </p:spPr>
+      </p:sp>
+      <p:sp>
+        <p:nvSpPr>
+          <p:cNvPr id="152" name="Text 150"/>
+          <p:cNvSpPr/>
+          <p:nvPr/>
+        </p:nvSpPr>
+        <p:spPr>
+          <a:xfrm>
+            <a:off x="4914900" y="3587750"/>
             <a:ext cx="203200" cy="152400"/>
           </a:xfrm>
           <a:prstGeom prst="rect">
@@ -5219,13 +5877,13 @@
       </p:sp>
       <p:sp>
         <p:nvSpPr>
-          <p:cNvPr id="122" name="Text 101"/>
-          <p:cNvSpPr/>
-          <p:nvPr/>
-        </p:nvSpPr>
-        <p:spPr>
-          <a:xfrm>
-            <a:off x="4940300" y="3759200"/>
+          <p:cNvPr id="153" name="Text 151"/>
+          <p:cNvSpPr/>
+          <p:nvPr/>
+        </p:nvSpPr>
+        <p:spPr>
+          <a:xfrm>
+            <a:off x="4914900" y="3759200"/>
             <a:ext cx="203200" cy="152400"/>
           </a:xfrm>
           <a:prstGeom prst="rect">
@@ -5258,13 +5916,13 @@
       </p:sp>
       <p:sp>
         <p:nvSpPr>
-          <p:cNvPr id="123" name="Text 102"/>
-          <p:cNvSpPr/>
-          <p:nvPr/>
-        </p:nvSpPr>
-        <p:spPr>
-          <a:xfrm>
-            <a:off x="4940300" y="3975100"/>
+          <p:cNvPr id="154" name="Text 152"/>
+          <p:cNvSpPr/>
+          <p:nvPr/>
+        </p:nvSpPr>
+        <p:spPr>
+          <a:xfrm>
+            <a:off x="4914900" y="3975100"/>
             <a:ext cx="203200" cy="152400"/>
           </a:xfrm>
           <a:prstGeom prst="rect">
@@ -5297,7 +5955,7 @@
       </p:sp>
       <p:sp>
         <p:nvSpPr>
-          <p:cNvPr id="124" name="Text 103"/>
+          <p:cNvPr id="155" name="Text 153"/>
           <p:cNvSpPr/>
           <p:nvPr/>
         </p:nvSpPr>
@@ -5336,7 +5994,7 @@
       </p:sp>
       <p:sp>
         <p:nvSpPr>
-          <p:cNvPr id="125" name="Text 104"/>
+          <p:cNvPr id="156" name="Text 154"/>
           <p:cNvSpPr/>
           <p:nvPr/>
         </p:nvSpPr>
@@ -5375,7 +6033,7 @@
       </p:sp>
       <p:sp>
         <p:nvSpPr>
-          <p:cNvPr id="126" name="Text 105"/>
+          <p:cNvPr id="157" name="Text 155"/>
           <p:cNvSpPr/>
           <p:nvPr/>
         </p:nvSpPr>
@@ -5414,7 +6072,7 @@
       </p:sp>
       <p:sp>
         <p:nvSpPr>
-          <p:cNvPr id="127" name="Shape 106"/>
+          <p:cNvPr id="158" name="Shape 156"/>
           <p:cNvSpPr/>
           <p:nvPr/>
         </p:nvSpPr>
@@ -5439,7 +6097,7 @@
       </p:sp>
       <p:sp>
         <p:nvSpPr>
-          <p:cNvPr id="128" name="Text 107"/>
+          <p:cNvPr id="159" name="Text 157"/>
           <p:cNvSpPr/>
           <p:nvPr/>
         </p:nvSpPr>

</xml_diff>